<commit_message>
Final submission — notebook & deck synced (cnnindonesia + Tempo + Appendix A fix)
</commit_message>
<xml_diff>
--- a/deck/Maverick_Case_Study_Novindra.pptx
+++ b/deck/Maverick_Case_Study_Novindra.pptx
@@ -7708,7 +7708,7 @@
                 <a:ea typeface="Calibri" pitchFamily="34" charset="-122"/>
                 <a:cs typeface="Calibri" pitchFamily="34" charset="-120"/>
               </a:rPr>
-              <a:t>Satu-satunya outlet yang masuk Top-5 di KEDUA daftar — peringkat #4 by volume (164 artikel) dan #3 by engagement (avg 97.8). Konsisten produktif sekaligus konsisten beresonansi. Klien wajib menjadikannya Tier-1 VIP partner.</a:t>
+              <a:t>Dua outlet menembus kedua Top-5 — kompas.tv (#4 vol · #3 eng) dan cnnindonesia.com (#2 vol · #4 eng). Tapi kompas.tv unggul sebagai Sweet Spot karena rasio engagement (97.8) hampir 2× CNN (56.5) dengan volume tetap kompetitif. Klien wajib menjadikannya Tier-1 VIP partner.</a:t>
             </a:r>
             <a:endParaRPr lang="en-US" sz="1100" dirty="0"/>
           </a:p>
@@ -10511,7 +10511,7 @@
                 <a:ea typeface="Calibri" pitchFamily="34" charset="-122"/>
                 <a:cs typeface="Calibri" pitchFamily="34" charset="-120"/>
               </a:rPr>
-              <a:t>Anchor outlet — satu-satunya yang masuk Top-5 baik volume maupun engagement. ROI tertinggi: jangkauan tayang tinggi + kualitas interaksi terjaga. Ideal untuk Live Index widget &amp; feature stories.</a:t>
+              <a:t>Anchor outlet — di Top-5 baik volume (#4) maupun engagement (#3), dengan rasio engagement hampir 2× cnnindonesia.com (97.8 vs 56.5). ROI tertinggi: reach tinggi + kualitas interaksi terjaga. Ideal untuk Live Index widget &amp; feature stories eksklusif.</a:t>
             </a:r>
             <a:endParaRPr lang="en-US" sz="1000" dirty="0"/>
           </a:p>
@@ -11072,7 +11072,7 @@
                 <a:ea typeface="Calibri" pitchFamily="34" charset="-122"/>
                 <a:cs typeface="Calibri" pitchFamily="34" charset="-120"/>
               </a:rPr>
-              <a:t>Tempo Network (metro/tekno/data)</a:t>
+              <a:t>Tempo Network (metro.tempo.co)</a:t>
             </a:r>
             <a:endParaRPr lang="en-US" sz="1700" dirty="0"/>
           </a:p>
@@ -11111,7 +11111,7 @@
                 <a:ea typeface="Calibri" pitchFamily="34" charset="-122"/>
                 <a:cs typeface="Calibri" pitchFamily="34" charset="-120"/>
               </a:rPr>
-              <a:t>Elite Audience  ·  60+ artikel  ·  avg 50–100 engagement</a:t>
+              <a:t>Elite Audience  ·  35 artikel  ·  avg 53.0 engagement</a:t>
             </a:r>
             <a:endParaRPr lang="en-US" sz="1000" dirty="0"/>
           </a:p>
@@ -11150,7 +11150,7 @@
                 <a:ea typeface="Calibri" pitchFamily="34" charset="-122"/>
                 <a:cs typeface="Calibri" pitchFamily="34" charset="-120"/>
               </a:rPr>
-              <a:t>Distribusi opini terbesar di Twitter elit. Cocok untuk advokasi kebijakan &amp; framing publik bila kampanye butuh leverage struktural.</a:t>
+              <a:t>Top-5 by engagement (#5). Distribusi opini terbesar di Twitter elit. Cocok untuk advokasi kebijakan &amp; framing publik bila kampanye butuh leverage struktural.</a:t>
             </a:r>
             <a:endParaRPr lang="en-US" sz="1000" dirty="0"/>
           </a:p>

</xml_diff>